<commit_message>
Toan 12 T21-25: sua cong thuc mat dau tru/phep toan trong ngoac; slide On tap Cau 9; sua loi giai cau 4 bai cung co Bai 4
Co-Authored-By: Claude Opus 5.5 <noreply@anthropic.com>
</commit_message>
<xml_diff>
--- a/mon/toan/slide/lop12/Slide_TOAN12_BaiTapCuoiChuong1_T23-24.pptx
+++ b/mon/toan/slide/lop12/Slide_TOAN12_BaiTapCuoiChuong1_T23-24.pptx
@@ -29251,7 +29251,7 @@
                   <m:oMath xmlns:m="http://schemas.openxmlformats.org/officeDocument/2006/math" xmlns:wpc="http://schemas.microsoft.com/office/word/2010/wordprocessingCanvas" xmlns:mo="http://schemas.microsoft.com/office/mac/office/2008/main" xmlns:mv="urn:schemas-microsoft-com:mac:vml" xmlns:o="urn:schemas-microsoft-com:office:office" xmlns:v="urn:schemas-microsoft-com:vml" xmlns:wp14="http://schemas.microsoft.com/office/word/2010/wordprocessingDrawing" xmlns:wp="http://schemas.openxmlformats.org/drawingml/2006/wordprocessingDrawing" xmlns:w10="urn:schemas-microsoft-com:office:word" xmlns:w="http://schemas.openxmlformats.org/wordprocessingml/2006/main" xmlns:w14="http://schemas.microsoft.com/office/word/2010/wordml" xmlns:wpg="http://schemas.microsoft.com/office/word/2010/wordprocessingGroup" xmlns:wpi="http://schemas.microsoft.com/office/word/2010/wordprocessingInk" xmlns:wne="http://schemas.microsoft.com/office/word/2006/wordml" xmlns:wps="http://schemas.microsoft.com/office/word/2010/wordprocessingShape">
                     <m:d>
                       <m:dPr>
-                        <m:sepChr m:val="≠"/>
+                        <m:sepChr m:val=""/>
                       </m:dPr>
                       <m:e>
                         <m:r>
@@ -29263,8 +29263,15 @@
                           </a:rPr>
                           <m:t>a</m:t>
                         </m:r>
-                      </m:e>
-                      <m:e>
+                        <m:r>
+                          <a:rPr lang="vi-VN" sz="2200" b="0">
+                            <a:solidFill>
+                              <a:srgbClr val="1E293B"/>
+                            </a:solidFill>
+                            <a:latin typeface="Cambria Math" panose="02040503050406030204" pitchFamily="18" charset="0"/>
+                          </a:rPr>
+                          <m:t>≠</m:t>
+                        </m:r>
                         <m:r>
                           <a:rPr lang="vi-VN" sz="2200" b="0">
                             <a:solidFill>
@@ -29464,7 +29471,7 @@
                 </a:r>
                 <a:r>
                   <a:rPr lang="vi-VN"/>
-                  <a:t>(a 0)</a:t>
+                  <a:t>(a≠0)</a:t>
                 </a:r>
                 <a:r>
                   <a:rPr sz="2200">

</xml_diff>